<commit_message>
Rework demo deck around measurement: show-up rate, cost per head, reply rate, follow-through; adds What Gets Measured and 8/1/0 proof-numerals slides
Co-authored-by: Cursor <cursoragent@cursor.com>
</commit_message>
<xml_diff>
--- a/docs/cook-demo.pptx
+++ b/docs/cook-demo.pptx
@@ -3233,7 +3233,7 @@
         </p:nvSpPr>
         <p:spPr>
           <a:xfrm>
-            <a:off x="749808" y="1417320"/>
+            <a:off x="749808" y="1371600"/>
             <a:ext cx="10789920" cy="2468880"/>
           </a:xfrm>
           <a:prstGeom prst="rect">
@@ -3259,7 +3259,7 @@
               </a:spcAft>
             </a:pPr>
             <a:r>
-              <a:rPr sz="19000" b="1" i="0" spc="-200">
+              <a:rPr sz="18000" b="1" i="0" spc="-200">
                 <a:solidFill>
                   <a:srgbClr val="1B1712"/>
                 </a:solidFill>
@@ -3278,7 +3278,7 @@
         </p:nvSpPr>
         <p:spPr>
           <a:xfrm>
-            <a:off x="822960" y="3931920"/>
+            <a:off x="822960" y="3794760"/>
             <a:ext cx="10515600" cy="914400"/>
           </a:xfrm>
           <a:prstGeom prst="rect">
@@ -3307,7 +3307,7 @@
                 </a:solidFill>
                 <a:latin typeface="Georgia"/>
               </a:rPr>
-              <a:t>Every club event, </a:t>
+              <a:t>Club events, </a:t>
             </a:r>
             <a:r>
               <a:rPr sz="3000" b="0" i="1">
@@ -3316,7 +3316,7 @@
                 </a:solidFill>
                 <a:latin typeface="Georgia"/>
               </a:rPr>
-              <a:t>plated.</a:t>
+              <a:t>measured.</a:t>
             </a:r>
           </a:p>
         </p:txBody>
@@ -3329,8 +3329,8 @@
         </p:nvSpPr>
         <p:spPr>
           <a:xfrm>
-            <a:off x="822960" y="4754880"/>
-            <a:ext cx="9601200" cy="1097280"/>
+            <a:off x="822960" y="4617720"/>
+            <a:ext cx="9875520" cy="1097280"/>
           </a:xfrm>
           <a:prstGeom prst="rect">
             <a:avLst/>
@@ -3358,7 +3358,7 @@
                 </a:solidFill>
                 <a:latin typeface="Segoe UI"/>
               </a:rPr>
-              <a:t>One home for the plan, the invite, the orders &amp; the morning after —</a:t>
+              <a:t>COOK runs the event &amp; keeps the score — turnout, spend, replies, follow-through —</a:t>
             </a:r>
           </a:p>
           <a:p>
@@ -3377,7 +3377,7 @@
                 </a:solidFill>
                 <a:latin typeface="Segoe UI"/>
               </a:rPr>
-              <a:t>with an AI kitchen staff that preps everything &amp; waits for your yes.</a:t>
+              <a:t>so every event makes the next one sharper.</a:t>
             </a:r>
           </a:p>
         </p:txBody>
@@ -3684,7 +3684,7 @@
         </p:nvSpPr>
         <p:spPr>
           <a:xfrm>
-            <a:off x="822960" y="1234440"/>
+            <a:off x="822960" y="1188720"/>
             <a:ext cx="10543032" cy="1554480"/>
           </a:xfrm>
           <a:prstGeom prst="rect">
@@ -3716,7 +3716,7 @@
                 </a:solidFill>
                 <a:latin typeface="Georgia"/>
               </a:rPr>
-              <a:t>Club Events Run on Chaos</a:t>
+              <a:t>Nobody Keeps the Score</a:t>
             </a:r>
           </a:p>
         </p:txBody>
@@ -3800,7 +3800,7 @@
                 </a:solidFill>
                 <a:latin typeface="Segoe UI"/>
               </a:rPr>
-              <a:t>The plan lives in a doc.</a:t>
+              <a:t>Nobody knows what worked.</a:t>
             </a:r>
           </a:p>
           <a:p>
@@ -3822,7 +3822,7 @@
                 </a:solidFill>
                 <a:latin typeface="Segoe UI"/>
               </a:rPr>
-              <a:t>The invite lives on Luma. The supplies sit in an Amazon cart. The food is a group chat.</a:t>
+              <a:t>The event ends, the group chat moves on, &amp; the spreadsheet of who showed up never happens.</a:t>
             </a:r>
           </a:p>
         </p:txBody>
@@ -3906,7 +3906,7 @@
                 </a:solidFill>
                 <a:latin typeface="Segoe UI"/>
               </a:rPr>
-              <a:t>Officers cook for free.</a:t>
+              <a:t>The next event starts from zero.</a:t>
             </a:r>
           </a:p>
           <a:p>
@@ -3928,7 +3928,7 @@
                 </a:solidFill>
                 <a:latin typeface="Segoe UI"/>
               </a:rPr>
-              <a:t>Thin budgets, campus rooms, volunteer labor — the same scramble, every single event.</a:t>
+              <a:t>No attendance history, no cost records, no follow-up list — every officer re-learns the same lessons.</a:t>
             </a:r>
           </a:p>
         </p:txBody>
@@ -4034,7 +4034,7 @@
                 </a:solidFill>
                 <a:latin typeface="Segoe UI"/>
               </a:rPr>
-              <a:t>They either just chat about the work — or worse, send &amp; spend without asking.</a:t>
+              <a:t>They chat about the work, or send &amp; spend without asking. None of them count anything.</a:t>
             </a:r>
           </a:p>
         </p:txBody>
@@ -4246,7 +4246,7 @@
         </p:nvSpPr>
         <p:spPr>
           <a:xfrm>
-            <a:off x="822960" y="1234440"/>
+            <a:off x="822960" y="1188720"/>
             <a:ext cx="10543032" cy="1554480"/>
           </a:xfrm>
           <a:prstGeom prst="rect">
@@ -4272,13 +4272,13 @@
               </a:spcAft>
             </a:pPr>
             <a:r>
-              <a:rPr sz="5200" b="0" i="1">
+              <a:rPr sz="4600" b="0" i="1">
                 <a:solidFill>
                   <a:srgbClr val="1B1712"/>
                 </a:solidFill>
                 <a:latin typeface="Georgia"/>
               </a:rPr>
-              <a:t>One Kitchen. One Pass.</a:t>
+              <a:t>Run the Event. Keep the Score.</a:t>
             </a:r>
           </a:p>
         </p:txBody>
@@ -4291,7 +4291,7 @@
         </p:nvSpPr>
         <p:spPr>
           <a:xfrm>
-            <a:off x="822960" y="2377440"/>
+            <a:off x="822960" y="2331720"/>
             <a:ext cx="3364992" cy="2834640"/>
           </a:xfrm>
           <a:prstGeom prst="roundRect">
@@ -4339,7 +4339,7 @@
         </p:nvSpPr>
         <p:spPr>
           <a:xfrm>
-            <a:off x="1115568" y="2697480"/>
+            <a:off x="1115568" y="2651760"/>
             <a:ext cx="2779776" cy="2194560"/>
           </a:xfrm>
           <a:prstGeom prst="rect">
@@ -4403,7 +4403,7 @@
         </p:nvSpPr>
         <p:spPr>
           <a:xfrm>
-            <a:off x="4416552" y="2377440"/>
+            <a:off x="4416552" y="2331720"/>
             <a:ext cx="3364992" cy="2834640"/>
           </a:xfrm>
           <a:prstGeom prst="roundRect">
@@ -4451,7 +4451,7 @@
         </p:nvSpPr>
         <p:spPr>
           <a:xfrm>
-            <a:off x="4709160" y="2697480"/>
+            <a:off x="4709160" y="2651760"/>
             <a:ext cx="2779776" cy="2194560"/>
           </a:xfrm>
           <a:prstGeom prst="rect">
@@ -4515,7 +4515,7 @@
         </p:nvSpPr>
         <p:spPr>
           <a:xfrm>
-            <a:off x="8010144" y="2377440"/>
+            <a:off x="8010144" y="2331720"/>
             <a:ext cx="3364992" cy="2834640"/>
           </a:xfrm>
           <a:prstGeom prst="roundRect">
@@ -4563,7 +4563,7 @@
         </p:nvSpPr>
         <p:spPr>
           <a:xfrm>
-            <a:off x="8302752" y="2697480"/>
+            <a:off x="8302752" y="2651760"/>
             <a:ext cx="2779776" cy="2194560"/>
           </a:xfrm>
           <a:prstGeom prst="rect">
@@ -4592,7 +4592,7 @@
                 </a:solidFill>
                 <a:latin typeface="Georgia"/>
               </a:rPr>
-              <a:t>The Stamp</a:t>
+              <a:t>The Scorecard</a:t>
             </a:r>
           </a:p>
           <a:p>
@@ -4614,7 +4614,7 @@
                 </a:solidFill>
                 <a:latin typeface="Segoe UI"/>
               </a:rPr>
-              <a:t>Nothing sends, publishes, or charges without your explicit yes. Every single time.</a:t>
+              <a:t>Every event records its numbers — turnout, spend, replies, follow-through — and feeds them forward.</a:t>
             </a:r>
           </a:p>
         </p:txBody>
@@ -4627,7 +4627,7 @@
         </p:nvSpPr>
         <p:spPr>
           <a:xfrm>
-            <a:off x="822960" y="5715000"/>
+            <a:off x="822960" y="5669280"/>
             <a:ext cx="10543032" cy="731520"/>
           </a:xfrm>
           <a:prstGeom prst="rect">
@@ -4665,7 +4665,7 @@
                 </a:solidFill>
                 <a:latin typeface="Segoe UI"/>
               </a:rPr>
-              <a:t>One spine, skills on the side.</a:t>
+              <a:t>One spine, skills on the side, numbers on the record.</a:t>
             </a:r>
           </a:p>
         </p:txBody>
@@ -4822,7 +4822,7 @@
                 </a:solidFill>
                 <a:latin typeface="Segoe UI"/>
               </a:rPr>
-              <a:t>   ·   THE APP</a:t>
+              <a:t>   ·   WHAT GETS MEASURED</a:t>
             </a:r>
           </a:p>
         </p:txBody>
@@ -4877,7 +4877,7 @@
         </p:nvSpPr>
         <p:spPr>
           <a:xfrm>
-            <a:off x="822960" y="1234440"/>
+            <a:off x="822960" y="1188720"/>
             <a:ext cx="10543032" cy="1554480"/>
           </a:xfrm>
           <a:prstGeom prst="rect">
@@ -4909,7 +4909,7 @@
                 </a:solidFill>
                 <a:latin typeface="Georgia"/>
               </a:rPr>
-              <a:t>Tonight’s Service, at a Glance</a:t>
+              <a:t>What Gets Measured</a:t>
             </a:r>
           </a:p>
         </p:txBody>
@@ -4999,7 +4999,7 @@
                 </a:solidFill>
                 <a:latin typeface="Segoe UI"/>
               </a:rPr>
-              <a:t>Home Digest</a:t>
+              <a:t>Show-up rate</a:t>
             </a:r>
           </a:p>
           <a:p>
@@ -5021,7 +5021,7 @@
                 </a:solidFill>
                 <a:latin typeface="Segoe UI"/>
               </a:rPr>
-              <a:t>This week’s events, open tasks &amp; pending drafts — the moment you open the app.</a:t>
+              <a:t>RSVPs vs. actual check-ins — the number every club argues about, settled.</a:t>
             </a:r>
           </a:p>
         </p:txBody>
@@ -5111,7 +5111,7 @@
                 </a:solidFill>
                 <a:latin typeface="Segoe UI"/>
               </a:rPr>
-              <a:t>Event Page</a:t>
+              <a:t>Cost per head</a:t>
             </a:r>
           </a:p>
           <a:p>
@@ -5133,7 +5133,7 @@
                 </a:solidFill>
                 <a:latin typeface="Segoe UI"/>
               </a:rPr>
-              <a:t>Brief, task list &amp; run-of-show on one screen. No tab-switching mid-crunch.</a:t>
+              <a:t>Supplies &amp; food, divided by who came. Budgets stop being guesses.</a:t>
             </a:r>
           </a:p>
         </p:txBody>
@@ -5223,7 +5223,7 @@
                 </a:solidFill>
                 <a:latin typeface="Segoe UI"/>
               </a:rPr>
-              <a:t>Approvals Queue</a:t>
+              <a:t>Reply rate</a:t>
             </a:r>
           </a:p>
           <a:p>
@@ -5245,7 +5245,7 @@
                 </a:solidFill>
                 <a:latin typeface="Segoe UI"/>
               </a:rPr>
-              <a:t>Every outreach draft waits here: draft, awaiting approval, sent. Nothing sends itself.</a:t>
+              <a:t>Outreach answered vs. sent — which partners &amp; channels actually respond.</a:t>
             </a:r>
           </a:p>
         </p:txBody>
@@ -5335,7 +5335,7 @@
                 </a:solidFill>
                 <a:latin typeface="Segoe UI"/>
               </a:rPr>
-              <a:t>Guest Snapshot</a:t>
+              <a:t>Follow-through</a:t>
             </a:r>
           </a:p>
           <a:p>
@@ -5357,7 +5357,58 @@
                 </a:solidFill>
                 <a:latin typeface="Segoe UI"/>
               </a:rPr>
-              <a:t>Partners, contacts, attendance &amp; follow-ups — the next event starts smarter.</a:t>
+              <a:t>Post-event tasks closed vs. opened. The debrief that actually happens.</a:t>
+            </a:r>
+          </a:p>
+        </p:txBody>
+      </p:sp>
+      <p:sp>
+        <p:nvSpPr>
+          <p:cNvPr id="15" name="TextBox 14"/>
+          <p:cNvSpPr txBox="1"/>
+          <p:nvPr/>
+        </p:nvSpPr>
+        <p:spPr>
+          <a:xfrm>
+            <a:off x="822960" y="5806440"/>
+            <a:ext cx="10543032" cy="548640"/>
+          </a:xfrm>
+          <a:prstGeom prst="rect">
+            <a:avLst/>
+          </a:prstGeom>
+          <a:noFill/>
+        </p:spPr>
+        <p:txBody>
+          <a:bodyPr wrap="square" anchor="t">
+            <a:spAutoFit/>
+          </a:bodyPr>
+          <a:lstStyle/>
+          <a:p>
+            <a:pPr algn="l">
+              <a:spcBef>
+                <a:spcPts val="0"/>
+              </a:spcBef>
+              <a:spcAft>
+                <a:spcPts val="600"/>
+              </a:spcAft>
+            </a:pPr>
+            <a:r>
+              <a:rPr sz="1500" b="1" i="0">
+                <a:solidFill>
+                  <a:srgbClr val="1B1712"/>
+                </a:solidFill>
+                <a:latin typeface="Segoe UI"/>
+              </a:rPr>
+              <a:t>No PII in the numbers. </a:t>
+            </a:r>
+            <a:r>
+              <a:rPr sz="1500" b="0" i="0">
+                <a:solidFill>
+                  <a:srgbClr val="6E6455"/>
+                </a:solidFill>
+                <a:latin typeface="Segoe UI"/>
+              </a:rPr>
+              <a:t>Counts &amp; rates, never names — attendance, not surveillance.</a:t>
             </a:r>
           </a:p>
         </p:txBody>
@@ -5569,7 +5620,7 @@
         </p:nvSpPr>
         <p:spPr>
           <a:xfrm>
-            <a:off x="822960" y="1234440"/>
+            <a:off x="822960" y="1188720"/>
             <a:ext cx="10543032" cy="1554480"/>
           </a:xfrm>
           <a:prstGeom prst="rect">
@@ -5601,7 +5652,7 @@
                 </a:solidFill>
                 <a:latin typeface="Georgia"/>
               </a:rPr>
-              <a:t>A Prep Cook for Every Station</a:t>
+              <a:t>Every Station Feeds the Score</a:t>
             </a:r>
           </a:p>
         </p:txBody>
@@ -5674,7 +5725,7 @@
                 </a:solidFill>
                 <a:latin typeface="Segoe UI"/>
               </a:rPr>
-              <a:t>Concept, budget &amp; run-of-show — then a lock gate before anyone spends a dollar.</a:t>
+              <a:t>Sets targets up front: headcount, budget, capacity. You can’t beat a number you never set.</a:t>
             </a:r>
           </a:p>
         </p:txBody>
@@ -5747,7 +5798,7 @@
                 </a:solidFill>
                 <a:latin typeface="Segoe UI"/>
               </a:rPr>
-              <a:t>Learns your club’s vibes, colors &amp; voice first. Drafts the invite. Never publishes.</a:t>
+              <a:t>The draft invite is where RSVP tracking starts — signups flow back into the record.</a:t>
             </a:r>
           </a:p>
         </p:txBody>
@@ -5820,7 +5871,7 @@
                 </a:solidFill>
                 <a:latin typeface="Segoe UI"/>
               </a:rPr>
-              <a:t>Only quality passes: 500+ reviews, 4.6+ stars, arrives 2+ days early. Stops before checkout.</a:t>
+              <a:t>500+ reviews, 4.6+ stars, arrives 2+ days early — quality bars you can audit, with the spend logged.</a:t>
             </a:r>
           </a:p>
         </p:txBody>
@@ -5893,7 +5944,7 @@
                 </a:solidFill>
                 <a:latin typeface="Segoe UI"/>
               </a:rPr>
-              <a:t>Any vendor you pick. Order sheet, runner logistics, reimbursement — out of the supplies cart.</a:t>
+              <a:t>Order sheet, runner logistics, receipt — cost per head falls out of the paperwork.</a:t>
             </a:r>
           </a:p>
         </p:txBody>
@@ -5944,7 +5995,7 @@
                 </a:solidFill>
                 <a:latin typeface="Segoe UI"/>
               </a:rPr>
-              <a:t>Personal Daily Brief</a:t>
+              <a:t>Metrics &amp; Follow-Ups</a:t>
             </a:r>
           </a:p>
           <a:p>
@@ -5966,7 +6017,7 @@
                 </a:solidFill>
                 <a:latin typeface="Segoe UI"/>
               </a:rPr>
-              <a:t>Reads your Notion, calendar &amp; email each morning: what’s on, what’s waiting, a plan. Read-only.</a:t>
+              <a:t>Reads the event’s records after the fact: what hit target, what slipped, who to thank.</a:t>
             </a:r>
           </a:p>
         </p:txBody>
@@ -6017,7 +6068,7 @@
                 </a:solidFill>
                 <a:latin typeface="Segoe UI"/>
               </a:rPr>
-              <a:t>Ops · Outreach · Metrics</a:t>
+              <a:t>Personal Daily Brief</a:t>
             </a:r>
           </a:p>
           <a:p>
@@ -6039,7 +6090,7 @@
                 </a:solidFill>
                 <a:latin typeface="Segoe UI"/>
               </a:rPr>
-              <a:t>In-app helpers for task breakdowns, drafts to the Approvals queue &amp; post-event follow-ups.</a:t>
+              <a:t>Each morning: what’s on, what’s waiting on you, what’s overdue — your own follow-through, counted.</a:t>
             </a:r>
           </a:p>
         </p:txBody>
@@ -6196,7 +6247,7 @@
                 </a:solidFill>
                 <a:latin typeface="Segoe UI"/>
               </a:rPr>
-              <a:t>   ·   THE FLOW</a:t>
+              <a:t>   ·   THE LOOP</a:t>
             </a:r>
           </a:p>
         </p:txBody>
@@ -6251,7 +6302,7 @@
         </p:nvSpPr>
         <p:spPr>
           <a:xfrm>
-            <a:off x="822960" y="1234440"/>
+            <a:off x="822960" y="1188720"/>
             <a:ext cx="10543032" cy="1554480"/>
           </a:xfrm>
           <a:prstGeom prst="rect">
@@ -6277,13 +6328,13 @@
               </a:spcAft>
             </a:pPr>
             <a:r>
-              <a:rPr sz="5200" b="0" i="1">
+              <a:rPr sz="4600" b="0" i="1">
                 <a:solidFill>
                   <a:srgbClr val="1B1712"/>
                 </a:solidFill>
                 <a:latin typeface="Georgia"/>
               </a:rPr>
-              <a:t>First Spark to Last Plate</a:t>
+              <a:t>Every Event Sharpens the Next</a:t>
             </a:r>
           </a:p>
         </p:txBody>
@@ -6296,7 +6347,7 @@
         </p:nvSpPr>
         <p:spPr>
           <a:xfrm>
-            <a:off x="822960" y="2267712"/>
+            <a:off x="822960" y="2221992"/>
             <a:ext cx="1005840" cy="822960"/>
           </a:xfrm>
           <a:prstGeom prst="rect">
@@ -6338,7 +6389,7 @@
         </p:nvSpPr>
         <p:spPr>
           <a:xfrm>
-            <a:off x="1920240" y="2377440"/>
+            <a:off x="1920240" y="2331720"/>
             <a:ext cx="8595360" cy="914400"/>
           </a:xfrm>
           <a:prstGeom prst="rect">
@@ -6367,7 +6418,7 @@
                 </a:solidFill>
                 <a:latin typeface="Segoe UI"/>
               </a:rPr>
-              <a:t>Plan</a:t>
+              <a:t>Set targets</a:t>
             </a:r>
           </a:p>
           <a:p>
@@ -6389,7 +6440,7 @@
                 </a:solidFill>
                 <a:latin typeface="Segoe UI"/>
               </a:rPr>
-              <a:t>Concept, budget &amp; run-of-show come together — then everything locks: date, headcount, budget.</a:t>
+              <a:t>Headcount, budget &amp; capacity lock in at the plan stage — before anyone spends a dollar.</a:t>
             </a:r>
           </a:p>
         </p:txBody>
@@ -6402,7 +6453,7 @@
         </p:nvSpPr>
         <p:spPr>
           <a:xfrm>
-            <a:off x="1920240" y="3236976"/>
+            <a:off x="1920240" y="3191256"/>
             <a:ext cx="9445752" cy="12700"/>
           </a:xfrm>
           <a:prstGeom prst="rect">
@@ -6446,7 +6497,7 @@
         </p:nvSpPr>
         <p:spPr>
           <a:xfrm>
-            <a:off x="822960" y="3255264"/>
+            <a:off x="822960" y="3209544"/>
             <a:ext cx="1005840" cy="822960"/>
           </a:xfrm>
           <a:prstGeom prst="rect">
@@ -6488,7 +6539,7 @@
         </p:nvSpPr>
         <p:spPr>
           <a:xfrm>
-            <a:off x="1920240" y="3364992"/>
+            <a:off x="1920240" y="3319272"/>
             <a:ext cx="8595360" cy="914400"/>
           </a:xfrm>
           <a:prstGeom prst="rect">
@@ -6517,7 +6568,7 @@
                 </a:solidFill>
                 <a:latin typeface="Segoe UI"/>
               </a:rPr>
-              <a:t>Invite</a:t>
+              <a:t>Run the night</a:t>
             </a:r>
           </a:p>
           <a:p>
@@ -6539,7 +6590,7 @@
                 </a:solidFill>
                 <a:latin typeface="Segoe UI"/>
               </a:rPr>
-              <a:t>The Luma draft is built from your club’s look &amp; voice, shown to you, and held.</a:t>
+              <a:t>Check-ins, spend &amp; outreach land in the record as the event happens, not after from memory.</a:t>
             </a:r>
           </a:p>
         </p:txBody>
@@ -6552,7 +6603,7 @@
         </p:nvSpPr>
         <p:spPr>
           <a:xfrm>
-            <a:off x="1920240" y="4224528"/>
+            <a:off x="1920240" y="4178808"/>
             <a:ext cx="9445752" cy="12700"/>
           </a:xfrm>
           <a:prstGeom prst="rect">
@@ -6596,7 +6647,7 @@
         </p:nvSpPr>
         <p:spPr>
           <a:xfrm>
-            <a:off x="822960" y="4242816"/>
+            <a:off x="822960" y="4197096"/>
             <a:ext cx="1005840" cy="822960"/>
           </a:xfrm>
           <a:prstGeom prst="rect">
@@ -6638,7 +6689,7 @@
         </p:nvSpPr>
         <p:spPr>
           <a:xfrm>
-            <a:off x="1920240" y="4352544"/>
+            <a:off x="1920240" y="4306824"/>
             <a:ext cx="8595360" cy="914400"/>
           </a:xfrm>
           <a:prstGeom prst="rect">
@@ -6667,7 +6718,7 @@
                 </a:solidFill>
                 <a:latin typeface="Segoe UI"/>
               </a:rPr>
-              <a:t>Order</a:t>
+              <a:t>Read the score</a:t>
             </a:r>
           </a:p>
           <a:p>
@@ -6689,7 +6740,7 @@
                 </a:solidFill>
                 <a:latin typeface="Segoe UI"/>
               </a:rPr>
-              <a:t>Supplies verified against the quality bar; the food run planned separately. Both stop before payment.</a:t>
+              <a:t>Show-up rate, cost per head, reply rate — against the targets you set in step 1.</a:t>
             </a:r>
           </a:p>
         </p:txBody>
@@ -6702,7 +6753,7 @@
         </p:nvSpPr>
         <p:spPr>
           <a:xfrm>
-            <a:off x="1920240" y="5212080"/>
+            <a:off x="1920240" y="5166360"/>
             <a:ext cx="9445752" cy="12700"/>
           </a:xfrm>
           <a:prstGeom prst="rect">
@@ -6746,7 +6797,7 @@
         </p:nvSpPr>
         <p:spPr>
           <a:xfrm>
-            <a:off x="822960" y="5230368"/>
+            <a:off x="822960" y="5184648"/>
             <a:ext cx="1005840" cy="822960"/>
           </a:xfrm>
           <a:prstGeom prst="rect">
@@ -6788,7 +6839,7 @@
         </p:nvSpPr>
         <p:spPr>
           <a:xfrm>
-            <a:off x="1920240" y="5340096"/>
+            <a:off x="1920240" y="5294376"/>
             <a:ext cx="8595360" cy="914400"/>
           </a:xfrm>
           <a:prstGeom prst="rect">
@@ -6817,7 +6868,7 @@
                 </a:solidFill>
                 <a:latin typeface="Segoe UI"/>
               </a:rPr>
-              <a:t>Serve &amp; Debrief</a:t>
+              <a:t>Feed it forward</a:t>
             </a:r>
           </a:p>
           <a:p>
@@ -6839,7 +6890,7 @@
                 </a:solidFill>
                 <a:latin typeface="Segoe UI"/>
               </a:rPr>
-              <a:t>The day-of checklist runs the night; attendance &amp; follow-ups feed the next event.</a:t>
+              <a:t>Follow-ups go out, lessons attach to the next plan, targets adjust. The loop closes.</a:t>
             </a:r>
           </a:p>
         </p:txBody>
@@ -7106,7 +7157,7 @@
         </p:nvSpPr>
         <p:spPr>
           <a:xfrm>
-            <a:off x="822960" y="1234440"/>
+            <a:off x="822960" y="1188720"/>
             <a:ext cx="10543032" cy="1554480"/>
           </a:xfrm>
           <a:prstGeom prst="rect">
@@ -7151,7 +7202,7 @@
         </p:nvSpPr>
         <p:spPr>
           <a:xfrm>
-            <a:off x="822960" y="1828800"/>
+            <a:off x="822960" y="1783080"/>
             <a:ext cx="10543032" cy="822960"/>
           </a:xfrm>
           <a:prstGeom prst="rect">
@@ -7193,7 +7244,7 @@
         </p:nvSpPr>
         <p:spPr>
           <a:xfrm>
-            <a:off x="822960" y="2743200"/>
+            <a:off x="822960" y="2697480"/>
             <a:ext cx="457200" cy="457200"/>
           </a:xfrm>
           <a:prstGeom prst="rect">
@@ -7235,7 +7286,7 @@
         </p:nvSpPr>
         <p:spPr>
           <a:xfrm>
-            <a:off x="1417320" y="2743200"/>
+            <a:off x="1417320" y="2697480"/>
             <a:ext cx="7863840" cy="822960"/>
           </a:xfrm>
           <a:prstGeom prst="rect">
@@ -7289,7 +7340,7 @@
         </p:nvSpPr>
         <p:spPr>
           <a:xfrm>
-            <a:off x="822960" y="3584448"/>
+            <a:off x="822960" y="3538728"/>
             <a:ext cx="457200" cy="457200"/>
           </a:xfrm>
           <a:prstGeom prst="rect">
@@ -7331,7 +7382,7 @@
         </p:nvSpPr>
         <p:spPr>
           <a:xfrm>
-            <a:off x="1417320" y="3584448"/>
+            <a:off x="1417320" y="3538728"/>
             <a:ext cx="7863840" cy="822960"/>
           </a:xfrm>
           <a:prstGeom prst="rect">
@@ -7385,7 +7436,7 @@
         </p:nvSpPr>
         <p:spPr>
           <a:xfrm>
-            <a:off x="822960" y="4425696"/>
+            <a:off x="822960" y="4379976"/>
             <a:ext cx="457200" cy="457200"/>
           </a:xfrm>
           <a:prstGeom prst="rect">
@@ -7427,7 +7478,7 @@
         </p:nvSpPr>
         <p:spPr>
           <a:xfrm>
-            <a:off x="1417320" y="4425696"/>
+            <a:off x="1417320" y="4379976"/>
             <a:ext cx="7863840" cy="822960"/>
           </a:xfrm>
           <a:prstGeom prst="rect">
@@ -7459,7 +7510,7 @@
                 </a:solidFill>
                 <a:latin typeface="Segoe UI"/>
               </a:rPr>
-              <a:t>Every claim shows its source — </a:t>
+              <a:t>Every number shows its source — </a:t>
             </a:r>
             <a:r>
               <a:rPr sz="1350" b="0" i="0">
@@ -7468,7 +7519,7 @@
                 </a:solidFill>
                 <a:latin typeface="Segoe UI"/>
               </a:rPr>
-              <a:t>briefings tag each item — calendar, Notion, or email — so you can verify in two clicks.</a:t>
+              <a:t>each metric traces to the record it came from — verify any claim in two clicks.</a:t>
             </a:r>
           </a:p>
         </p:txBody>
@@ -7481,7 +7532,7 @@
         </p:nvSpPr>
         <p:spPr>
           <a:xfrm>
-            <a:off x="822960" y="5266944"/>
+            <a:off x="822960" y="5221224"/>
             <a:ext cx="457200" cy="457200"/>
           </a:xfrm>
           <a:prstGeom prst="rect">
@@ -7523,7 +7574,7 @@
         </p:nvSpPr>
         <p:spPr>
           <a:xfrm>
-            <a:off x="1417320" y="5266944"/>
+            <a:off x="1417320" y="5221224"/>
             <a:ext cx="7863840" cy="822960"/>
           </a:xfrm>
           <a:prstGeom prst="rect">
@@ -7555,7 +7606,7 @@
                 </a:solidFill>
                 <a:latin typeface="Segoe UI"/>
               </a:rPr>
-              <a:t>Skills are plain files — </a:t>
+              <a:t>Counts, not people — </a:t>
             </a:r>
             <a:r>
               <a:rPr sz="1350" b="0" i="0">
@@ -7564,7 +7615,7 @@
                 </a:solidFill>
                 <a:latin typeface="Segoe UI"/>
               </a:rPr>
-              <a:t>each skill is one readable document. Review it, copy it, hand it to another agent.</a:t>
+              <a:t>attendance &amp; rates only. No names, no message bodies, no PII in the numbers.</a:t>
             </a:r>
           </a:p>
         </p:txBody>
@@ -7577,7 +7628,7 @@
         </p:nvSpPr>
         <p:spPr>
           <a:xfrm rot="21060000">
-            <a:off x="9464040" y="3383280"/>
+            <a:off x="9464040" y="3337560"/>
             <a:ext cx="2286000" cy="566928"/>
           </a:xfrm>
           <a:prstGeom prst="roundRect">
@@ -7632,7 +7683,7 @@
         </p:nvSpPr>
         <p:spPr>
           <a:xfrm rot="300000">
-            <a:off x="9784080" y="4434840"/>
+            <a:off x="9784080" y="4389120"/>
             <a:ext cx="1920240" cy="512064"/>
           </a:xfrm>
           <a:prstGeom prst="roundRect">
@@ -7886,7 +7937,7 @@
         </p:nvSpPr>
         <p:spPr>
           <a:xfrm>
-            <a:off x="822960" y="1234440"/>
+            <a:off x="822960" y="1188720"/>
             <a:ext cx="10543032" cy="1554480"/>
           </a:xfrm>
           <a:prstGeom prst="rect">
@@ -7918,34 +7969,300 @@
                 </a:solidFill>
                 <a:latin typeface="Georgia"/>
               </a:rPr>
-              <a:t>Serving Tonight</a:t>
-            </a:r>
-          </a:p>
-        </p:txBody>
-      </p:sp>
-      <p:sp>
-        <p:nvSpPr>
-          <p:cNvPr id="7" name="Rounded Rectangle 6"/>
+              <a:t>Keeping Score Tonight</a:t>
+            </a:r>
+          </a:p>
+        </p:txBody>
+      </p:sp>
+      <p:sp>
+        <p:nvSpPr>
+          <p:cNvPr id="7" name="TextBox 6"/>
+          <p:cNvSpPr txBox="1"/>
+          <p:nvPr/>
+        </p:nvSpPr>
+        <p:spPr>
+          <a:xfrm>
+            <a:off x="822960" y="2240280"/>
+            <a:ext cx="3108960" cy="1005840"/>
+          </a:xfrm>
+          <a:prstGeom prst="rect">
+            <a:avLst/>
+          </a:prstGeom>
+          <a:noFill/>
+        </p:spPr>
+        <p:txBody>
+          <a:bodyPr wrap="square" anchor="t">
+            <a:spAutoFit/>
+          </a:bodyPr>
+          <a:lstStyle/>
+          <a:p>
+            <a:pPr algn="l">
+              <a:lnSpc>
+                <a:spcPct val="95000"/>
+              </a:lnSpc>
+              <a:spcBef>
+                <a:spcPts val="0"/>
+              </a:spcBef>
+              <a:spcAft>
+                <a:spcPts val="600"/>
+              </a:spcAft>
+            </a:pPr>
+            <a:r>
+              <a:rPr sz="7200" b="1" i="0" spc="-100">
+                <a:solidFill>
+                  <a:srgbClr val="D44A24"/>
+                </a:solidFill>
+                <a:latin typeface="Georgia"/>
+              </a:rPr>
+              <a:t>8</a:t>
+            </a:r>
+          </a:p>
+        </p:txBody>
+      </p:sp>
+      <p:sp>
+        <p:nvSpPr>
+          <p:cNvPr id="8" name="TextBox 7"/>
+          <p:cNvSpPr txBox="1"/>
+          <p:nvPr/>
+        </p:nvSpPr>
+        <p:spPr>
+          <a:xfrm>
+            <a:off x="822960" y="3264408"/>
+            <a:ext cx="3108960" cy="822960"/>
+          </a:xfrm>
+          <a:prstGeom prst="rect">
+            <a:avLst/>
+          </a:prstGeom>
+          <a:noFill/>
+        </p:spPr>
+        <p:txBody>
+          <a:bodyPr wrap="square" anchor="t">
+            <a:spAutoFit/>
+          </a:bodyPr>
+          <a:lstStyle/>
+          <a:p>
+            <a:pPr algn="l">
+              <a:lnSpc>
+                <a:spcPct val="115000"/>
+              </a:lnSpc>
+              <a:spcBef>
+                <a:spcPts val="0"/>
+              </a:spcBef>
+              <a:spcAft>
+                <a:spcPts val="600"/>
+              </a:spcAft>
+            </a:pPr>
+            <a:r>
+              <a:rPr sz="1350" b="0" i="0">
+                <a:solidFill>
+                  <a:srgbClr val="6E6455"/>
+                </a:solidFill>
+                <a:latin typeface="Segoe UI"/>
+              </a:rPr>
+              <a:t>skills written &amp; ready — plan, invite, supplies, food, metrics, brief &amp; more</a:t>
+            </a:r>
+          </a:p>
+        </p:txBody>
+      </p:sp>
+      <p:sp>
+        <p:nvSpPr>
+          <p:cNvPr id="9" name="TextBox 8"/>
+          <p:cNvSpPr txBox="1"/>
+          <p:nvPr/>
+        </p:nvSpPr>
+        <p:spPr>
+          <a:xfrm>
+            <a:off x="4434840" y="2240280"/>
+            <a:ext cx="3108960" cy="1005840"/>
+          </a:xfrm>
+          <a:prstGeom prst="rect">
+            <a:avLst/>
+          </a:prstGeom>
+          <a:noFill/>
+        </p:spPr>
+        <p:txBody>
+          <a:bodyPr wrap="square" anchor="t">
+            <a:spAutoFit/>
+          </a:bodyPr>
+          <a:lstStyle/>
+          <a:p>
+            <a:pPr algn="l">
+              <a:lnSpc>
+                <a:spcPct val="95000"/>
+              </a:lnSpc>
+              <a:spcBef>
+                <a:spcPts val="0"/>
+              </a:spcBef>
+              <a:spcAft>
+                <a:spcPts val="600"/>
+              </a:spcAft>
+            </a:pPr>
+            <a:r>
+              <a:rPr sz="7200" b="1" i="0" spc="-100">
+                <a:solidFill>
+                  <a:srgbClr val="D44A24"/>
+                </a:solidFill>
+                <a:latin typeface="Georgia"/>
+              </a:rPr>
+              <a:t>1</a:t>
+            </a:r>
+          </a:p>
+        </p:txBody>
+      </p:sp>
+      <p:sp>
+        <p:nvSpPr>
+          <p:cNvPr id="10" name="TextBox 9"/>
+          <p:cNvSpPr txBox="1"/>
+          <p:nvPr/>
+        </p:nvSpPr>
+        <p:spPr>
+          <a:xfrm>
+            <a:off x="4434840" y="3264408"/>
+            <a:ext cx="3108960" cy="822960"/>
+          </a:xfrm>
+          <a:prstGeom prst="rect">
+            <a:avLst/>
+          </a:prstGeom>
+          <a:noFill/>
+        </p:spPr>
+        <p:txBody>
+          <a:bodyPr wrap="square" anchor="t">
+            <a:spAutoFit/>
+          </a:bodyPr>
+          <a:lstStyle/>
+          <a:p>
+            <a:pPr algn="l">
+              <a:lnSpc>
+                <a:spcPct val="115000"/>
+              </a:lnSpc>
+              <a:spcBef>
+                <a:spcPts val="0"/>
+              </a:spcBef>
+              <a:spcAft>
+                <a:spcPts val="600"/>
+              </a:spcAft>
+            </a:pPr>
+            <a:r>
+              <a:rPr sz="1350" b="0" i="0">
+                <a:solidFill>
+                  <a:srgbClr val="6E6455"/>
+                </a:solidFill>
+                <a:latin typeface="Segoe UI"/>
+              </a:rPr>
+              <a:t>queue every draft, cart &amp; invite must pass through before anything happens</a:t>
+            </a:r>
+          </a:p>
+        </p:txBody>
+      </p:sp>
+      <p:sp>
+        <p:nvSpPr>
+          <p:cNvPr id="11" name="TextBox 10"/>
+          <p:cNvSpPr txBox="1"/>
+          <p:nvPr/>
+        </p:nvSpPr>
+        <p:spPr>
+          <a:xfrm>
+            <a:off x="8046720" y="2240280"/>
+            <a:ext cx="3108960" cy="1005840"/>
+          </a:xfrm>
+          <a:prstGeom prst="rect">
+            <a:avLst/>
+          </a:prstGeom>
+          <a:noFill/>
+        </p:spPr>
+        <p:txBody>
+          <a:bodyPr wrap="square" anchor="t">
+            <a:spAutoFit/>
+          </a:bodyPr>
+          <a:lstStyle/>
+          <a:p>
+            <a:pPr algn="l">
+              <a:lnSpc>
+                <a:spcPct val="95000"/>
+              </a:lnSpc>
+              <a:spcBef>
+                <a:spcPts val="0"/>
+              </a:spcBef>
+              <a:spcAft>
+                <a:spcPts val="600"/>
+              </a:spcAft>
+            </a:pPr>
+            <a:r>
+              <a:rPr sz="7200" b="1" i="0" spc="-100">
+                <a:solidFill>
+                  <a:srgbClr val="D44A24"/>
+                </a:solidFill>
+                <a:latin typeface="Georgia"/>
+              </a:rPr>
+              <a:t>0</a:t>
+            </a:r>
+          </a:p>
+        </p:txBody>
+      </p:sp>
+      <p:sp>
+        <p:nvSpPr>
+          <p:cNvPr id="12" name="TextBox 11"/>
+          <p:cNvSpPr txBox="1"/>
+          <p:nvPr/>
+        </p:nvSpPr>
+        <p:spPr>
+          <a:xfrm>
+            <a:off x="8046720" y="3264408"/>
+            <a:ext cx="3108960" cy="822960"/>
+          </a:xfrm>
+          <a:prstGeom prst="rect">
+            <a:avLst/>
+          </a:prstGeom>
+          <a:noFill/>
+        </p:spPr>
+        <p:txBody>
+          <a:bodyPr wrap="square" anchor="t">
+            <a:spAutoFit/>
+          </a:bodyPr>
+          <a:lstStyle/>
+          <a:p>
+            <a:pPr algn="l">
+              <a:lnSpc>
+                <a:spcPct val="115000"/>
+              </a:lnSpc>
+              <a:spcBef>
+                <a:spcPts val="0"/>
+              </a:spcBef>
+              <a:spcAft>
+                <a:spcPts val="600"/>
+              </a:spcAft>
+            </a:pPr>
+            <a:r>
+              <a:rPr sz="1350" b="0" i="0">
+                <a:solidFill>
+                  <a:srgbClr val="6E6455"/>
+                </a:solidFill>
+                <a:latin typeface="Segoe UI"/>
+              </a:rPr>
+              <a:t>messages sent, orders placed, or invites published without a human yes</a:t>
+            </a:r>
+          </a:p>
+        </p:txBody>
+      </p:sp>
+      <p:sp>
+        <p:nvSpPr>
+          <p:cNvPr id="13" name="Rectangle 12"/>
           <p:cNvSpPr/>
           <p:nvPr/>
         </p:nvSpPr>
         <p:spPr>
           <a:xfrm>
-            <a:off x="822960" y="2377440"/>
-            <a:ext cx="3364992" cy="3291840"/>
-          </a:xfrm>
-          <a:prstGeom prst="roundRect">
-            <a:avLst>
-              <a:gd name="adj" fmla="val 4500"/>
-            </a:avLst>
+            <a:off x="822960" y="4206240"/>
+            <a:ext cx="10543032" cy="12700"/>
+          </a:xfrm>
+          <a:prstGeom prst="rect">
+            <a:avLst/>
           </a:prstGeom>
           <a:solidFill>
-            <a:srgbClr val="FFFCF6"/>
+            <a:srgbClr val="D9CFBE"/>
           </a:solidFill>
-          <a:ln w="12700">
-            <a:solidFill>
-              <a:srgbClr val="D9CFBE"/>
-            </a:solidFill>
+          <a:ln>
+            <a:noFill/>
           </a:ln>
           <a:effectLst/>
         </p:spPr>
@@ -7973,14 +8290,14 @@
       </p:sp>
       <p:sp>
         <p:nvSpPr>
-          <p:cNvPr id="8" name="TextBox 7"/>
+          <p:cNvPr id="14" name="TextBox 13"/>
           <p:cNvSpPr txBox="1"/>
           <p:nvPr/>
         </p:nvSpPr>
         <p:spPr>
           <a:xfrm>
-            <a:off x="1115568" y="2670048"/>
-            <a:ext cx="2779776" cy="2743200"/>
+            <a:off x="822960" y="4434840"/>
+            <a:ext cx="3364992" cy="1554480"/>
           </a:xfrm>
           <a:prstGeom prst="rect">
             <a:avLst/>
@@ -7998,11 +8315,11 @@
                 <a:spcPts val="0"/>
               </a:spcBef>
               <a:spcAft>
-                <a:spcPts val="1200"/>
-              </a:spcAft>
-            </a:pPr>
-            <a:r>
-              <a:rPr sz="2000" b="0" i="1">
+                <a:spcPts val="600"/>
+              </a:spcAft>
+            </a:pPr>
+            <a:r>
+              <a:rPr sz="1800" b="0" i="1">
                 <a:solidFill>
                   <a:srgbClr val="1B1712"/>
                 </a:solidFill>
@@ -8014,156 +8331,37 @@
           <a:p>
             <a:pPr algn="l">
               <a:lnSpc>
-                <a:spcPct val="115000"/>
+                <a:spcPct val="120000"/>
               </a:lnSpc>
               <a:spcBef>
                 <a:spcPts val="0"/>
               </a:spcBef>
               <a:spcAft>
-                <a:spcPts val="1000"/>
-              </a:spcAft>
-            </a:pPr>
-            <a:r>
-              <a:rPr sz="1300" b="1" i="0">
-                <a:solidFill>
-                  <a:srgbClr val="D44A24"/>
-                </a:solidFill>
-                <a:latin typeface="Segoe UI"/>
-              </a:rPr>
-              <a:t>—  </a:t>
-            </a:r>
-            <a:r>
-              <a:rPr sz="1300" b="0" i="0">
+                <a:spcPts val="600"/>
+              </a:spcAft>
+            </a:pPr>
+            <a:r>
+              <a:rPr sz="1250" b="0" i="0">
                 <a:solidFill>
                   <a:srgbClr val="1B1712"/>
                 </a:solidFill>
                 <a:latin typeface="Segoe UI"/>
               </a:rPr>
-              <a:t>Full event management: tasks, run-of-show, partners</a:t>
-            </a:r>
-          </a:p>
-          <a:p>
-            <a:pPr algn="l">
-              <a:lnSpc>
-                <a:spcPct val="115000"/>
-              </a:lnSpc>
-              <a:spcBef>
-                <a:spcPts val="0"/>
-              </a:spcBef>
-              <a:spcAft>
-                <a:spcPts val="1000"/>
-              </a:spcAft>
-            </a:pPr>
-            <a:r>
-              <a:rPr sz="1300" b="1" i="0">
-                <a:solidFill>
-                  <a:srgbClr val="D44A24"/>
-                </a:solidFill>
-                <a:latin typeface="Segoe UI"/>
-              </a:rPr>
-              <a:t>—  </a:t>
-            </a:r>
-            <a:r>
-              <a:rPr sz="1300" b="0" i="0">
-                <a:solidFill>
-                  <a:srgbClr val="1B1712"/>
-                </a:solidFill>
-                <a:latin typeface="Segoe UI"/>
-              </a:rPr>
-              <a:t>The Approvals queue, working end to end</a:t>
-            </a:r>
-          </a:p>
-          <a:p>
-            <a:pPr algn="l">
-              <a:lnSpc>
-                <a:spcPct val="115000"/>
-              </a:lnSpc>
-              <a:spcBef>
-                <a:spcPts val="0"/>
-              </a:spcBef>
-              <a:spcAft>
-                <a:spcPts val="1000"/>
-              </a:spcAft>
-            </a:pPr>
-            <a:r>
-              <a:rPr sz="1300" b="1" i="0">
-                <a:solidFill>
-                  <a:srgbClr val="D44A24"/>
-                </a:solidFill>
-                <a:latin typeface="Segoe UI"/>
-              </a:rPr>
-              <a:t>—  </a:t>
-            </a:r>
-            <a:r>
-              <a:rPr sz="1300" b="0" i="0">
-                <a:solidFill>
-                  <a:srgbClr val="1B1712"/>
-                </a:solidFill>
-                <a:latin typeface="Segoe UI"/>
-              </a:rPr>
-              <a:t>A seeded demo night, ready to walk through</a:t>
-            </a:r>
-          </a:p>
-        </p:txBody>
-      </p:sp>
-      <p:sp>
-        <p:nvSpPr>
-          <p:cNvPr id="9" name="Rounded Rectangle 8"/>
-          <p:cNvSpPr/>
-          <p:nvPr/>
-        </p:nvSpPr>
-        <p:spPr>
-          <a:xfrm>
-            <a:off x="4416552" y="2377440"/>
-            <a:ext cx="3364992" cy="3291840"/>
-          </a:xfrm>
-          <a:prstGeom prst="roundRect">
-            <a:avLst>
-              <a:gd name="adj" fmla="val 4500"/>
-            </a:avLst>
-          </a:prstGeom>
-          <a:solidFill>
-            <a:srgbClr val="FFFCF6"/>
-          </a:solidFill>
-          <a:ln w="12700">
-            <a:solidFill>
-              <a:srgbClr val="D9CFBE"/>
-            </a:solidFill>
-          </a:ln>
-          <a:effectLst/>
-        </p:spPr>
-        <p:style>
-          <a:lnRef idx="1">
-            <a:schemeClr val="accent1"/>
-          </a:lnRef>
-          <a:fillRef idx="3">
-            <a:schemeClr val="accent1"/>
-          </a:fillRef>
-          <a:effectRef idx="2">
-            <a:schemeClr val="accent1"/>
-          </a:effectRef>
-          <a:fontRef idx="minor">
-            <a:schemeClr val="lt1"/>
-          </a:fontRef>
-        </p:style>
-        <p:txBody>
-          <a:bodyPr rtlCol="0" anchor="ctr"/>
-          <a:lstStyle/>
-          <a:p>
-            <a:pPr algn="ctr"/>
-          </a:p>
-        </p:txBody>
-      </p:sp>
-      <p:sp>
-        <p:nvSpPr>
-          <p:cNvPr id="10" name="TextBox 9"/>
+              <a:t>Full event management, the Approvals queue &amp; a seeded demo night — ready to walk through now.</a:t>
+            </a:r>
+          </a:p>
+        </p:txBody>
+      </p:sp>
+      <p:sp>
+        <p:nvSpPr>
+          <p:cNvPr id="15" name="TextBox 14"/>
           <p:cNvSpPr txBox="1"/>
           <p:nvPr/>
         </p:nvSpPr>
         <p:spPr>
           <a:xfrm>
-            <a:off x="4709160" y="2670048"/>
-            <a:ext cx="2779776" cy="2743200"/>
+            <a:off x="4416552" y="4434840"/>
+            <a:ext cx="3364992" cy="1554480"/>
           </a:xfrm>
           <a:prstGeom prst="rect">
             <a:avLst/>
@@ -8181,11 +8379,11 @@
                 <a:spcPts val="0"/>
               </a:spcBef>
               <a:spcAft>
-                <a:spcPts val="1200"/>
-              </a:spcAft>
-            </a:pPr>
-            <a:r>
-              <a:rPr sz="2000" b="0" i="1">
+                <a:spcPts val="600"/>
+              </a:spcAft>
+            </a:pPr>
+            <a:r>
+              <a:rPr sz="1800" b="0" i="1">
                 <a:solidFill>
                   <a:srgbClr val="6E6455"/>
                 </a:solidFill>
@@ -8197,156 +8395,37 @@
           <a:p>
             <a:pPr algn="l">
               <a:lnSpc>
-                <a:spcPct val="115000"/>
+                <a:spcPct val="120000"/>
               </a:lnSpc>
               <a:spcBef>
                 <a:spcPts val="0"/>
               </a:spcBef>
               <a:spcAft>
-                <a:spcPts val="1000"/>
-              </a:spcAft>
-            </a:pPr>
-            <a:r>
-              <a:rPr sz="1300" b="1" i="0">
-                <a:solidFill>
-                  <a:srgbClr val="D44A24"/>
-                </a:solidFill>
-                <a:latin typeface="Segoe UI"/>
-              </a:rPr>
-              <a:t>—  </a:t>
-            </a:r>
-            <a:r>
-              <a:rPr sz="1300" b="0" i="0">
+                <a:spcPts val="600"/>
+              </a:spcAft>
+            </a:pPr>
+            <a:r>
+              <a:rPr sz="1250" b="0" i="0">
                 <a:solidFill>
                   <a:srgbClr val="6E6455"/>
                 </a:solidFill>
                 <a:latin typeface="Segoe UI"/>
               </a:rPr>
-              <a:t>AI skills answer with placeholders today</a:t>
-            </a:r>
-          </a:p>
-          <a:p>
-            <a:pPr algn="l">
-              <a:lnSpc>
-                <a:spcPct val="115000"/>
-              </a:lnSpc>
-              <a:spcBef>
-                <a:spcPts val="0"/>
-              </a:spcBef>
-              <a:spcAft>
-                <a:spcPts val="1000"/>
-              </a:spcAft>
-            </a:pPr>
-            <a:r>
-              <a:rPr sz="1300" b="1" i="0">
-                <a:solidFill>
-                  <a:srgbClr val="D44A24"/>
-                </a:solidFill>
-                <a:latin typeface="Segoe UI"/>
-              </a:rPr>
-              <a:t>—  </a:t>
-            </a:r>
-            <a:r>
-              <a:rPr sz="1300" b="0" i="0">
-                <a:solidFill>
-                  <a:srgbClr val="6E6455"/>
-                </a:solidFill>
-                <a:latin typeface="Segoe UI"/>
-              </a:rPr>
-              <a:t>Sign-in is a demo shortcut, not real accounts</a:t>
-            </a:r>
-          </a:p>
-          <a:p>
-            <a:pPr algn="l">
-              <a:lnSpc>
-                <a:spcPct val="115000"/>
-              </a:lnSpc>
-              <a:spcBef>
-                <a:spcPts val="0"/>
-              </a:spcBef>
-              <a:spcAft>
-                <a:spcPts val="1000"/>
-              </a:spcAft>
-            </a:pPr>
-            <a:r>
-              <a:rPr sz="1300" b="1" i="0">
-                <a:solidFill>
-                  <a:srgbClr val="D44A24"/>
-                </a:solidFill>
-                <a:latin typeface="Segoe UI"/>
-              </a:rPr>
-              <a:t>—  </a:t>
-            </a:r>
-            <a:r>
-              <a:rPr sz="1300" b="0" i="0">
-                <a:solidFill>
-                  <a:srgbClr val="6E6455"/>
-                </a:solidFill>
-                <a:latin typeface="Segoe UI"/>
-              </a:rPr>
-              <a:t>Approving a draft doesn’t send it yet</a:t>
-            </a:r>
-          </a:p>
-        </p:txBody>
-      </p:sp>
-      <p:sp>
-        <p:nvSpPr>
-          <p:cNvPr id="11" name="Rounded Rectangle 10"/>
-          <p:cNvSpPr/>
-          <p:nvPr/>
-        </p:nvSpPr>
-        <p:spPr>
-          <a:xfrm>
-            <a:off x="8010144" y="2377440"/>
-            <a:ext cx="3364992" cy="3291840"/>
-          </a:xfrm>
-          <a:prstGeom prst="roundRect">
-            <a:avLst>
-              <a:gd name="adj" fmla="val 4500"/>
-            </a:avLst>
-          </a:prstGeom>
-          <a:solidFill>
-            <a:srgbClr val="FFFCF6"/>
-          </a:solidFill>
-          <a:ln w="12700">
-            <a:solidFill>
-              <a:srgbClr val="D9CFBE"/>
-            </a:solidFill>
-          </a:ln>
-          <a:effectLst/>
-        </p:spPr>
-        <p:style>
-          <a:lnRef idx="1">
-            <a:schemeClr val="accent1"/>
-          </a:lnRef>
-          <a:fillRef idx="3">
-            <a:schemeClr val="accent1"/>
-          </a:fillRef>
-          <a:effectRef idx="2">
-            <a:schemeClr val="accent1"/>
-          </a:effectRef>
-          <a:fontRef idx="minor">
-            <a:schemeClr val="lt1"/>
-          </a:fontRef>
-        </p:style>
-        <p:txBody>
-          <a:bodyPr rtlCol="0" anchor="ctr"/>
-          <a:lstStyle/>
-          <a:p>
-            <a:pPr algn="ctr"/>
-          </a:p>
-        </p:txBody>
-      </p:sp>
-      <p:sp>
-        <p:nvSpPr>
-          <p:cNvPr id="12" name="TextBox 11"/>
+              <a:t>AI skills answer with placeholders today; sign-in is a demo shortcut; approved drafts don’t send yet.</a:t>
+            </a:r>
+          </a:p>
+        </p:txBody>
+      </p:sp>
+      <p:sp>
+        <p:nvSpPr>
+          <p:cNvPr id="16" name="TextBox 15"/>
           <p:cNvSpPr txBox="1"/>
           <p:nvPr/>
         </p:nvSpPr>
         <p:spPr>
           <a:xfrm>
-            <a:off x="8302752" y="2670048"/>
-            <a:ext cx="2779776" cy="2743200"/>
+            <a:off x="8010144" y="4434840"/>
+            <a:ext cx="3364992" cy="1554480"/>
           </a:xfrm>
           <a:prstGeom prst="rect">
             <a:avLst/>
@@ -8364,11 +8443,11 @@
                 <a:spcPts val="0"/>
               </a:spcBef>
               <a:spcAft>
-                <a:spcPts val="1200"/>
-              </a:spcAft>
-            </a:pPr>
-            <a:r>
-              <a:rPr sz="2000" b="0" i="1">
+                <a:spcPts val="600"/>
+              </a:spcAft>
+            </a:pPr>
+            <a:r>
+              <a:rPr sz="1800" b="0" i="1">
                 <a:solidFill>
                   <a:srgbClr val="D44A24"/>
                 </a:solidFill>
@@ -8380,107 +8459,36 @@
           <a:p>
             <a:pPr algn="l">
               <a:lnSpc>
-                <a:spcPct val="115000"/>
+                <a:spcPct val="120000"/>
               </a:lnSpc>
               <a:spcBef>
                 <a:spcPts val="0"/>
               </a:spcBef>
               <a:spcAft>
-                <a:spcPts val="1000"/>
-              </a:spcAft>
-            </a:pPr>
-            <a:r>
-              <a:rPr sz="1300" b="1" i="0">
-                <a:solidFill>
-                  <a:srgbClr val="D44A24"/>
-                </a:solidFill>
-                <a:latin typeface="Segoe UI"/>
-              </a:rPr>
-              <a:t>—  </a:t>
-            </a:r>
-            <a:r>
-              <a:rPr sz="1300" b="0" i="0">
+                <a:spcPts val="600"/>
+              </a:spcAft>
+            </a:pPr>
+            <a:r>
+              <a:rPr sz="1250" b="0" i="0">
                 <a:solidFill>
                   <a:srgbClr val="1B1712"/>
                 </a:solidFill>
                 <a:latin typeface="Segoe UI"/>
               </a:rPr>
-              <a:t>Plug a real model into the skills</a:t>
-            </a:r>
-          </a:p>
-          <a:p>
-            <a:pPr algn="l">
-              <a:lnSpc>
-                <a:spcPct val="115000"/>
-              </a:lnSpc>
-              <a:spcBef>
-                <a:spcPts val="0"/>
-              </a:spcBef>
-              <a:spcAft>
-                <a:spcPts val="1000"/>
-              </a:spcAft>
-            </a:pPr>
-            <a:r>
-              <a:rPr sz="1300" b="1" i="0">
-                <a:solidFill>
-                  <a:srgbClr val="D44A24"/>
-                </a:solidFill>
-                <a:latin typeface="Segoe UI"/>
-              </a:rPr>
-              <a:t>—  </a:t>
-            </a:r>
-            <a:r>
-              <a:rPr sz="1300" b="0" i="0">
-                <a:solidFill>
-                  <a:srgbClr val="1B1712"/>
-                </a:solidFill>
-                <a:latin typeface="Segoe UI"/>
-              </a:rPr>
-              <a:t>Real accounts &amp; per-club permissions</a:t>
-            </a:r>
-          </a:p>
-          <a:p>
-            <a:pPr algn="l">
-              <a:lnSpc>
-                <a:spcPct val="115000"/>
-              </a:lnSpc>
-              <a:spcBef>
-                <a:spcPts val="0"/>
-              </a:spcBef>
-              <a:spcAft>
-                <a:spcPts val="1000"/>
-              </a:spcAft>
-            </a:pPr>
-            <a:r>
-              <a:rPr sz="1300" b="1" i="0">
-                <a:solidFill>
-                  <a:srgbClr val="D44A24"/>
-                </a:solidFill>
-                <a:latin typeface="Segoe UI"/>
-              </a:rPr>
-              <a:t>—  </a:t>
-            </a:r>
-            <a:r>
-              <a:rPr sz="1300" b="0" i="0">
-                <a:solidFill>
-                  <a:srgbClr val="1B1712"/>
-                </a:solidFill>
-                <a:latin typeface="Segoe UI"/>
-              </a:rPr>
-              <a:t>Approved drafts actually send</a:t>
-            </a:r>
-          </a:p>
-        </p:txBody>
-      </p:sp>
-      <p:sp>
-        <p:nvSpPr>
-          <p:cNvPr id="13" name="TextBox 12"/>
+              <a:t>A real model behind the skills, real accounts &amp; per-club permissions, and live sending on approval.</a:t>
+            </a:r>
+          </a:p>
+        </p:txBody>
+      </p:sp>
+      <p:sp>
+        <p:nvSpPr>
+          <p:cNvPr id="17" name="TextBox 16"/>
           <p:cNvSpPr txBox="1"/>
           <p:nvPr/>
         </p:nvSpPr>
         <p:spPr>
           <a:xfrm>
-            <a:off x="822960" y="5943600"/>
+            <a:off x="822960" y="6035040"/>
             <a:ext cx="10543032" cy="548640"/>
           </a:xfrm>
           <a:prstGeom prst="rect">
@@ -8509,7 +8517,7 @@
                 </a:solidFill>
                 <a:latin typeface="Georgia"/>
               </a:rPr>
-              <a:t>The skills are already written. </a:t>
+              <a:t>The scoreboard is built. </a:t>
             </a:r>
             <a:r>
               <a:rPr sz="1700" b="0" i="1">

</xml_diff>